<commit_message>
Add full RetailRocket GPU results (Colab, 1 seed) to report, slides and viva notes
Co-Authored-By: Claude Opus 5.5 (1M context) <noreply@anthropic.com>
Claude-Session: https://claude.ai/code/session_01MG575YY538j1ZG5RKGBjFt
</commit_message>
<xml_diff>
--- a/report/midsem_slides.pptx
+++ b/report/midsem_slides.pptx
@@ -866,7 +866,7 @@
           <a:lstStyle/>
           <a:p>
             <a:r>
-              <a:t>Limitations: CPU only, so RetailRocket results are partial (1 seed, 2-3 epochs) until the GPU run finishes; the simulator's long-term dynamics are assumed, not learned from data, which is why s is a knob and s = 0 a control; 3 seeds only; KuaiRec replaced by MovieLens-1M; datasets from GitHub mirrors. Plan: first a regime map of the RL advantage over K in {1, 3, 5, 10}, strength s and gamma, compared to the toy-model prediction. Second, a neural MNL-Q re-ranker for K &gt; 1 with item-level choice and value heads and the exact LP assortment solver, trained offline with a conservative penalty. Third, baselines: a PISDR-style offline RL re-ranker from Yuan et al., SQN/EVAL heads, and a diversity/quality re-ranking heuristic. Then ablations on logging policy, candidate set size and gamma, closing the gap to the rating heuristic, and the full RetailRocket results.</a:t>
+              <a:t>Limitations: RetailRocket has 1 seed so far (the paper uses 5) and our HIST head has a loss-scaling bug; the simulator's long-term dynamics are assumed, not learned from data, which is why s is a knob and s = 0 a control; 3 seeds only; KuaiRec replaced by MovieLens-1M; datasets from GitHub mirrors. Plan: first a regime map of the RL advantage over K in {1, 3, 5, 10}, strength s and gamma, compared to the toy-model prediction. Second, a neural MNL-Q re-ranker for K &gt; 1 with item-level choice and value heads and the exact LP assortment solver, trained offline with a conservative penalty. Third, baselines: a PISDR-style offline RL re-ranker from Yuan et al., SQN/EVAL heads, and a diversity/quality re-ranking heuristic. Then ablations on logging policy, candidate set size and gamma, closing the gap to the rating heuristic, and the full RetailRocket results.</a:t>
             </a:r>
           </a:p>
         </p:txBody>
@@ -936,7 +936,7 @@
           <a:lstStyle/>
           <a:p>
             <a:r>
-              <a:t>Close with the one-sentence takeaway and invite questions. Likely questions: why the rating heuristic wins (our learned agents only see 2 logged sessions per user), whether the simulator is realistic (dynamics assumed; s = 0 is the control), and why SQN is below CE on RetailRocket (only 2-3 epochs; GPU run pending).</a:t>
+              <a:t>Close with the one-sentence takeaway and invite questions. Likely questions: why the rating heuristic wins (our learned agents only see 2 logged sessions per user), whether the simulator is realistic (dynamics assumed; s = 0 is the control), and why GRU4Rec shows no SQN gain on RetailRocket (one seed, 1-6% differences, CE stopped after 2 epochs).</a:t>
             </a:r>
           </a:p>
         </p:txBody>
@@ -1286,7 +1286,7 @@
           <a:lstStyle/>
           <a:p>
             <a:r>
-              <a:t>Labarca, Parra and Toro Icarte claim that adding an RL loss (SQN: a Q-head trained by TD with click reward 1 and purchase reward 5) to GRU4Rec or SASRec improves next-item prediction, but that non-RL auxiliary heads (EVAL, HIST) give similar gains, so the gain is representation learning, not RL. We reproduce their protocol: time-based 80/10/10 split, hidden 64, state length 10, gamma 0.5, full-ranking HR and NDCG, model selection on validation purchase NDCG@20. Our data matches: 195,524 sessions, 70,852 items, 57,269 purchases. Partial CPU results, 1 seed, 2-3 epochs: e.g. SASRec CE purchase HR@20 0.551, GRU4Rec CE purchase HR@20 0.458. Our purchase metrics are about twice the paper's (0.46 vs 0.23 for GRU4Rec CE HR@20): 67% of purchase targets equal the item viewed just before, 73% are in the 10-item history. So we compare relative differences between heads; SQN is still below CE after 2-3 epochs, which is too early to conclude. The full grid, 8 models x 5 seeds, runs on a Colab GPU.</a:t>
+              <a:t>Labarca, Parra and Toro Icarte claim that adding an RL loss (SQN: a Q-head trained by TD with click reward 1 and purchase reward 5) to GRU4Rec or SASRec improves next-item prediction, but that non-RL auxiliary heads (EVAL, HIST) give similar gains, so the gain is representation learning, not RL. We reproduce their protocol: time-based 80/10/10 split, hidden 64, state length 10, gamma 0.5, full-ranking HR and NDCG, model selection on validation purchase NDCG@20; our data matches the paper (195,524 sessions, 70,852 items, 57,269 purchases). The full grid, 2 backbones x 4 heads, ran on a Colab T4 GPU, 1 seed so far (paper: 5). SASRec reproduces the paper: purchase NDCG@20 SQN 0.448 and EVAL 0.450 vs CE 0.418, i.e. +7% and +8%; EVAL has no RL in it, yet matches SQN, which is the paper's point. GRU4Rec shows no gain: CE 0.342, SQN 0.323, EVAL 0.339; one seed, 1-6% differences, and CE stopped after 2 epochs, so this may be noise. HIST fails in our implementation (about 0.157 and 0.152): it regresses raw interaction counts with an unnormalised MSE that swamps the CE loss; that is our bug, to fix with a log(1+n) target, not evidence against the paper. Absolute purchase metrics are about twice the paper's (GRU CE HR@20 0.46 vs 0.23) because 67% of purchase targets equal the item viewed just before (73% in the 10-item history), so we compare relative differences.</a:t>
             </a:r>
           </a:p>
         </p:txBody>
@@ -8810,7 +8810,7 @@
                 </a:solidFill>
                 <a:latin typeface="Calibri"/>
               </a:rPr>
-              <a:t>CPU only: RetailRocket partial (1 seed, 2-3 epochs)</a:t>
+              <a:t>RetailRocket: 1 seed so far; HIST loss-scaling bug (fix: log(1+n))</a:t>
             </a:r>
           </a:p>
           <a:p>
@@ -9069,7 +9069,7 @@
                 </a:solidFill>
                 <a:latin typeface="Calibri"/>
               </a:rPr>
-              <a:t> to the rating heuristic; full RetailRocket GPU results</a:t>
+              <a:t> to the rating heuristic; RetailRocket: 5 seeds, fixed HIST</a:t>
             </a:r>
           </a:p>
         </p:txBody>
@@ -12326,7 +12326,7 @@
                 </a:solidFill>
                 <a:latin typeface="Calibri"/>
               </a:rPr>
-              <a:t>Status: S2, S3, S5-S9 done; S4 partial (full grid running on a Colab GPU)</a:t>
+              <a:t>Status: S2-S9 done; S4 full grid on a Colab GPU with 1 seed (more seeds next)</a:t>
             </a:r>
           </a:p>
           <a:p>
@@ -12503,8 +12503,8 @@
         </p:nvSpPr>
         <p:spPr>
           <a:xfrm>
-            <a:off x="548640" y="1280160"/>
-            <a:ext cx="11094415" cy="685800"/>
+            <a:off x="548640" y="1234440"/>
+            <a:ext cx="11094415" cy="640080"/>
           </a:xfrm>
           <a:prstGeom prst="rect">
             <a:avLst/>
@@ -12519,7 +12519,7 @@
           <a:p>
             <a:pPr algn="l"/>
             <a:r>
-              <a:rPr sz="1700" b="1" i="0">
+              <a:rPr sz="1600" b="1" i="0">
                 <a:solidFill>
                   <a:srgbClr val="1F3A5F"/>
                 </a:solidFill>
@@ -12528,7 +12528,7 @@
               <a:t>Claim:</a:t>
             </a:r>
             <a:r>
-              <a:rPr sz="1700" b="0" i="0">
+              <a:rPr sz="1600" b="0" i="0">
                 <a:solidFill>
                   <a:srgbClr val="222222"/>
                 </a:solidFill>
@@ -12548,8 +12548,8 @@
           <p:nvPr/>
         </p:nvGraphicFramePr>
         <p:xfrm>
-          <a:off x="548640" y="2148840"/>
-          <a:ext cx="6766558" cy="1920240"/>
+          <a:off x="548640" y="1965960"/>
+          <a:ext cx="6857998" cy="2962656"/>
         </p:xfrm>
         <a:graphic>
           <a:graphicData uri="http://schemas.openxmlformats.org/drawingml/2006/table">
@@ -12558,13 +12558,14 @@
                 <a:tableStyleId>{5C22544A-7EE6-4342-B048-85BDC9FD1C3A}</a:tableStyleId>
               </a:tblPr>
               <a:tblGrid>
-                <a:gridCol w="2069771"/>
-                <a:gridCol w="1512525"/>
-                <a:gridCol w="1034885"/>
-                <a:gridCol w="1034885"/>
-                <a:gridCol w="1114492"/>
+                <a:gridCol w="1285875"/>
+                <a:gridCol w="857250"/>
+                <a:gridCol w="1071562"/>
+                <a:gridCol w="1157287"/>
+                <a:gridCol w="1157287"/>
+                <a:gridCol w="1328737"/>
               </a:tblGrid>
-              <a:tr h="384048">
+              <a:tr h="329184">
                 <a:tc>
                   <a:txBody>
                     <a:bodyPr wrap="square"/>
@@ -12572,7 +12573,7 @@
                     <a:p>
                       <a:pPr algn="l"/>
                       <a:r>
-                        <a:rPr sz="1400" b="1" i="0">
+                        <a:rPr sz="1200" b="1" i="0">
                           <a:solidFill>
                             <a:srgbClr val="FFFFFF"/>
                           </a:solidFill>
@@ -12595,13 +12596,13 @@
                     <a:p>
                       <a:pPr algn="ctr"/>
                       <a:r>
-                        <a:rPr sz="1400" b="1" i="0">
+                        <a:rPr sz="1200" b="1" i="0">
                           <a:solidFill>
                             <a:srgbClr val="FFFFFF"/>
                           </a:solidFill>
                           <a:latin typeface="Calibri"/>
                         </a:rPr>
-                        <a:t>best epoch (of run)</a:t>
+                        <a:t>epochs</a:t>
                       </a:r>
                     </a:p>
                   </a:txBody>
@@ -12618,13 +12619,13 @@
                     <a:p>
                       <a:pPr algn="ctr"/>
                       <a:r>
-                        <a:rPr sz="1400" b="1" i="0">
+                        <a:rPr sz="1200" b="1" i="0">
                           <a:solidFill>
                             <a:srgbClr val="FFFFFF"/>
                           </a:solidFill>
                           <a:latin typeface="Calibri"/>
                         </a:rPr>
-                        <a:t>buy HR@5</a:t>
+                        <a:t>buy HR@20</a:t>
                       </a:r>
                     </a:p>
                   </a:txBody>
@@ -12641,13 +12642,13 @@
                     <a:p>
                       <a:pPr algn="ctr"/>
                       <a:r>
-                        <a:rPr sz="1400" b="1" i="0">
+                        <a:rPr sz="1200" b="1" i="0">
                           <a:solidFill>
                             <a:srgbClr val="FFFFFF"/>
                           </a:solidFill>
                           <a:latin typeface="Calibri"/>
                         </a:rPr>
-                        <a:t>buy HR@20</a:t>
+                        <a:t>buy NDCG@20</a:t>
                       </a:r>
                     </a:p>
                   </a:txBody>
@@ -12664,13 +12665,13 @@
                     <a:p>
                       <a:pPr algn="ctr"/>
                       <a:r>
-                        <a:rPr sz="1400" b="1" i="0">
+                        <a:rPr sz="1200" b="1" i="0">
                           <a:solidFill>
                             <a:srgbClr val="FFFFFF"/>
                           </a:solidFill>
                           <a:latin typeface="Calibri"/>
                         </a:rPr>
-                        <a:t>click HR@20</a:t>
+                        <a:t>click NDCG@20</a:t>
                       </a:r>
                     </a:p>
                   </a:txBody>
@@ -12680,8 +12681,31 @@
                     </a:solidFill>
                   </a:tcPr>
                 </a:tc>
+                <a:tc>
+                  <a:txBody>
+                    <a:bodyPr wrap="square"/>
+                    <a:lstStyle/>
+                    <a:p>
+                      <a:pPr algn="ctr"/>
+                      <a:r>
+                        <a:rPr sz="1200" b="1" i="0">
+                          <a:solidFill>
+                            <a:srgbClr val="FFFFFF"/>
+                          </a:solidFill>
+                          <a:latin typeface="Calibri"/>
+                        </a:rPr>
+                        <a:t>paper buy NDCG@20</a:t>
+                      </a:r>
+                    </a:p>
+                  </a:txBody>
+                  <a:tcPr marL="54864" marR="54864" marT="18288" marB="18288" anchor="ctr">
+                    <a:solidFill>
+                      <a:srgbClr val="1F3A5F"/>
+                    </a:solidFill>
+                  </a:tcPr>
+                </a:tc>
               </a:tr>
-              <a:tr h="384048">
+              <a:tr h="329184">
                 <a:tc>
                   <a:txBody>
                     <a:bodyPr wrap="square"/>
@@ -12689,13 +12713,13 @@
                     <a:p>
                       <a:pPr algn="l"/>
                       <a:r>
-                        <a:rPr sz="1400" b="0" i="0">
+                        <a:rPr sz="1200" b="0" i="0">
                           <a:solidFill>
                             <a:srgbClr val="222222"/>
                           </a:solidFill>
                           <a:latin typeface="Calibri"/>
                         </a:rPr>
-                        <a:t>GRU4Rec (CE)</a:t>
+                        <a:t>GRU</a:t>
                       </a:r>
                     </a:p>
                   </a:txBody>
@@ -12712,13 +12736,13 @@
                     <a:p>
                       <a:pPr algn="ctr"/>
                       <a:r>
-                        <a:rPr sz="1400" b="0" i="0">
+                        <a:rPr sz="1200" b="0" i="0">
                           <a:solidFill>
                             <a:srgbClr val="222222"/>
                           </a:solidFill>
                           <a:latin typeface="Calibri"/>
                         </a:rPr>
-                        <a:t>2 of 3</a:t>
+                        <a:t>2</a:t>
                       </a:r>
                     </a:p>
                   </a:txBody>
@@ -12735,13 +12759,13 @@
                     <a:p>
                       <a:pPr algn="ctr"/>
                       <a:r>
-                        <a:rPr sz="1400" b="0" i="0">
+                        <a:rPr sz="1200" b="0" i="0">
                           <a:solidFill>
                             <a:srgbClr val="222222"/>
                           </a:solidFill>
                           <a:latin typeface="Calibri"/>
                         </a:rPr>
-                        <a:t>0.380</a:t>
+                        <a:t>0.4595</a:t>
                       </a:r>
                     </a:p>
                   </a:txBody>
@@ -12758,13 +12782,13 @@
                     <a:p>
                       <a:pPr algn="ctr"/>
                       <a:r>
-                        <a:rPr sz="1400" b="0" i="0">
+                        <a:rPr sz="1200" b="0" i="0">
                           <a:solidFill>
                             <a:srgbClr val="222222"/>
                           </a:solidFill>
                           <a:latin typeface="Calibri"/>
                         </a:rPr>
-                        <a:t>0.458</a:t>
+                        <a:t>0.3424</a:t>
                       </a:r>
                     </a:p>
                   </a:txBody>
@@ -12781,13 +12805,13 @@
                     <a:p>
                       <a:pPr algn="ctr"/>
                       <a:r>
-                        <a:rPr sz="1400" b="0" i="0">
+                        <a:rPr sz="1200" b="0" i="0">
                           <a:solidFill>
                             <a:srgbClr val="222222"/>
                           </a:solidFill>
                           <a:latin typeface="Calibri"/>
                         </a:rPr>
-                        <a:t>0.292</a:t>
+                        <a:t>0.1959</a:t>
                       </a:r>
                     </a:p>
                   </a:txBody>
@@ -12797,8 +12821,31 @@
                     </a:solidFill>
                   </a:tcPr>
                 </a:tc>
+                <a:tc>
+                  <a:txBody>
+                    <a:bodyPr wrap="square"/>
+                    <a:lstStyle/>
+                    <a:p>
+                      <a:pPr algn="ctr"/>
+                      <a:r>
+                        <a:rPr sz="1200" b="0" i="0">
+                          <a:solidFill>
+                            <a:srgbClr val="222222"/>
+                          </a:solidFill>
+                          <a:latin typeface="Calibri"/>
+                        </a:rPr>
+                        <a:t>0.1450</a:t>
+                      </a:r>
+                    </a:p>
+                  </a:txBody>
+                  <a:tcPr marL="54864" marR="54864" marT="18288" marB="18288" anchor="ctr">
+                    <a:solidFill>
+                      <a:srgbClr val="FFFFFF"/>
+                    </a:solidFill>
+                  </a:tcPr>
+                </a:tc>
               </a:tr>
-              <a:tr h="384048">
+              <a:tr h="329184">
                 <a:tc>
                   <a:txBody>
                     <a:bodyPr wrap="square"/>
@@ -12806,13 +12853,13 @@
                     <a:p>
                       <a:pPr algn="l"/>
                       <a:r>
-                        <a:rPr sz="1400" b="0" i="0">
+                        <a:rPr sz="1200" b="0" i="0">
                           <a:solidFill>
                             <a:srgbClr val="222222"/>
                           </a:solidFill>
                           <a:latin typeface="Calibri"/>
                         </a:rPr>
-                        <a:t>GRU4Rec-SQN</a:t>
+                        <a:t>GRU-SQN</a:t>
                       </a:r>
                     </a:p>
                   </a:txBody>
@@ -12829,13 +12876,13 @@
                     <a:p>
                       <a:pPr algn="ctr"/>
                       <a:r>
-                        <a:rPr sz="1400" b="0" i="0">
+                        <a:rPr sz="1200" b="0" i="0">
                           <a:solidFill>
                             <a:srgbClr val="222222"/>
                           </a:solidFill>
                           <a:latin typeface="Calibri"/>
                         </a:rPr>
-                        <a:t>2 of 2</a:t>
+                        <a:t>5</a:t>
                       </a:r>
                     </a:p>
                   </a:txBody>
@@ -12852,13 +12899,13 @@
                     <a:p>
                       <a:pPr algn="ctr"/>
                       <a:r>
-                        <a:rPr sz="1400" b="0" i="0">
+                        <a:rPr sz="1200" b="0" i="0">
                           <a:solidFill>
                             <a:srgbClr val="222222"/>
                           </a:solidFill>
                           <a:latin typeface="Calibri"/>
                         </a:rPr>
-                        <a:t>0.327</a:t>
+                        <a:t>0.4311</a:t>
                       </a:r>
                     </a:p>
                   </a:txBody>
@@ -12875,13 +12922,13 @@
                     <a:p>
                       <a:pPr algn="ctr"/>
                       <a:r>
-                        <a:rPr sz="1400" b="0" i="0">
+                        <a:rPr sz="1200" b="0" i="0">
                           <a:solidFill>
                             <a:srgbClr val="222222"/>
                           </a:solidFill>
                           <a:latin typeface="Calibri"/>
                         </a:rPr>
-                        <a:t>0.386</a:t>
+                        <a:t>0.3233</a:t>
                       </a:r>
                     </a:p>
                   </a:txBody>
@@ -12898,13 +12945,13 @@
                     <a:p>
                       <a:pPr algn="ctr"/>
                       <a:r>
-                        <a:rPr sz="1400" b="0" i="0">
+                        <a:rPr sz="1200" b="0" i="0">
                           <a:solidFill>
                             <a:srgbClr val="222222"/>
                           </a:solidFill>
                           <a:latin typeface="Calibri"/>
                         </a:rPr>
-                        <a:t>0.249</a:t>
+                        <a:t>0.1989</a:t>
                       </a:r>
                     </a:p>
                   </a:txBody>
@@ -12914,8 +12961,31 @@
                     </a:solidFill>
                   </a:tcPr>
                 </a:tc>
+                <a:tc>
+                  <a:txBody>
+                    <a:bodyPr wrap="square"/>
+                    <a:lstStyle/>
+                    <a:p>
+                      <a:pPr algn="ctr"/>
+                      <a:r>
+                        <a:rPr sz="1200" b="0" i="0">
+                          <a:solidFill>
+                            <a:srgbClr val="222222"/>
+                          </a:solidFill>
+                          <a:latin typeface="Calibri"/>
+                        </a:rPr>
+                        <a:t>0.1743</a:t>
+                      </a:r>
+                    </a:p>
+                  </a:txBody>
+                  <a:tcPr marL="54864" marR="54864" marT="18288" marB="18288" anchor="ctr">
+                    <a:solidFill>
+                      <a:srgbClr val="EEF2F7"/>
+                    </a:solidFill>
+                  </a:tcPr>
+                </a:tc>
               </a:tr>
-              <a:tr h="384048">
+              <a:tr h="329184">
                 <a:tc>
                   <a:txBody>
                     <a:bodyPr wrap="square"/>
@@ -12923,13 +12993,13 @@
                     <a:p>
                       <a:pPr algn="l"/>
                       <a:r>
-                        <a:rPr sz="1400" b="0" i="0">
+                        <a:rPr sz="1200" b="0" i="0">
                           <a:solidFill>
                             <a:srgbClr val="222222"/>
                           </a:solidFill>
                           <a:latin typeface="Calibri"/>
                         </a:rPr>
-                        <a:t>SASRec (CE)</a:t>
+                        <a:t>GRU-EVAL</a:t>
                       </a:r>
                     </a:p>
                   </a:txBody>
@@ -12946,13 +13016,13 @@
                     <a:p>
                       <a:pPr algn="ctr"/>
                       <a:r>
-                        <a:rPr sz="1400" b="0" i="0">
+                        <a:rPr sz="1200" b="0" i="0">
                           <a:solidFill>
                             <a:srgbClr val="222222"/>
                           </a:solidFill>
                           <a:latin typeface="Calibri"/>
                         </a:rPr>
-                        <a:t>3 of 3</a:t>
+                        <a:t>3</a:t>
                       </a:r>
                     </a:p>
                   </a:txBody>
@@ -12969,13 +13039,13 @@
                     <a:p>
                       <a:pPr algn="ctr"/>
                       <a:r>
-                        <a:rPr sz="1400" b="0" i="0">
+                        <a:rPr sz="1200" b="0" i="0">
                           <a:solidFill>
                             <a:srgbClr val="222222"/>
                           </a:solidFill>
                           <a:latin typeface="Calibri"/>
                         </a:rPr>
-                        <a:t>0.469</a:t>
+                        <a:t>0.4497</a:t>
                       </a:r>
                     </a:p>
                   </a:txBody>
@@ -12992,13 +13062,13 @@
                     <a:p>
                       <a:pPr algn="ctr"/>
                       <a:r>
-                        <a:rPr sz="1400" b="0" i="0">
+                        <a:rPr sz="1200" b="0" i="0">
                           <a:solidFill>
                             <a:srgbClr val="222222"/>
                           </a:solidFill>
                           <a:latin typeface="Calibri"/>
                         </a:rPr>
-                        <a:t>0.551</a:t>
+                        <a:t>0.3386</a:t>
                       </a:r>
                     </a:p>
                   </a:txBody>
@@ -13015,13 +13085,13 @@
                     <a:p>
                       <a:pPr algn="ctr"/>
                       <a:r>
-                        <a:rPr sz="1400" b="0" i="0">
+                        <a:rPr sz="1200" b="0" i="0">
                           <a:solidFill>
                             <a:srgbClr val="222222"/>
                           </a:solidFill>
                           <a:latin typeface="Calibri"/>
                         </a:rPr>
-                        <a:t>0.346</a:t>
+                        <a:t>0.2064</a:t>
                       </a:r>
                     </a:p>
                   </a:txBody>
@@ -13031,8 +13101,31 @@
                     </a:solidFill>
                   </a:tcPr>
                 </a:tc>
+                <a:tc>
+                  <a:txBody>
+                    <a:bodyPr wrap="square"/>
+                    <a:lstStyle/>
+                    <a:p>
+                      <a:pPr algn="ctr"/>
+                      <a:r>
+                        <a:rPr sz="1200" b="0" i="0">
+                          <a:solidFill>
+                            <a:srgbClr val="222222"/>
+                          </a:solidFill>
+                          <a:latin typeface="Calibri"/>
+                        </a:rPr>
+                        <a:t>0.1762</a:t>
+                      </a:r>
+                    </a:p>
+                  </a:txBody>
+                  <a:tcPr marL="54864" marR="54864" marT="18288" marB="18288" anchor="ctr">
+                    <a:solidFill>
+                      <a:srgbClr val="FFFFFF"/>
+                    </a:solidFill>
+                  </a:tcPr>
+                </a:tc>
               </a:tr>
-              <a:tr h="384048">
+              <a:tr h="329184">
                 <a:tc>
                   <a:txBody>
                     <a:bodyPr wrap="square"/>
@@ -13040,13 +13133,13 @@
                     <a:p>
                       <a:pPr algn="l"/>
                       <a:r>
-                        <a:rPr sz="1400" b="0" i="0">
+                        <a:rPr sz="1200" b="0" i="0">
                           <a:solidFill>
                             <a:srgbClr val="222222"/>
                           </a:solidFill>
                           <a:latin typeface="Calibri"/>
                         </a:rPr>
-                        <a:t>SASRec-SQN</a:t>
+                        <a:t>GRU-HIST</a:t>
                       </a:r>
                     </a:p>
                   </a:txBody>
@@ -13063,13 +13156,13 @@
                     <a:p>
                       <a:pPr algn="ctr"/>
                       <a:r>
-                        <a:rPr sz="1400" b="0" i="0">
+                        <a:rPr sz="1200" b="0" i="0">
                           <a:solidFill>
                             <a:srgbClr val="222222"/>
                           </a:solidFill>
                           <a:latin typeface="Calibri"/>
                         </a:rPr>
-                        <a:t>2 of 2</a:t>
+                        <a:t>13</a:t>
                       </a:r>
                     </a:p>
                   </a:txBody>
@@ -13086,13 +13179,13 @@
                     <a:p>
                       <a:pPr algn="ctr"/>
                       <a:r>
-                        <a:rPr sz="1400" b="0" i="0">
+                        <a:rPr sz="1200" b="0" i="0">
                           <a:solidFill>
                             <a:srgbClr val="222222"/>
                           </a:solidFill>
                           <a:latin typeface="Calibri"/>
                         </a:rPr>
-                        <a:t>0.411</a:t>
+                        <a:t>0.2153</a:t>
                       </a:r>
                     </a:p>
                   </a:txBody>
@@ -13109,13 +13202,13 @@
                     <a:p>
                       <a:pPr algn="ctr"/>
                       <a:r>
-                        <a:rPr sz="1400" b="0" i="0">
+                        <a:rPr sz="1200" b="0" i="0">
                           <a:solidFill>
                             <a:srgbClr val="222222"/>
                           </a:solidFill>
                           <a:latin typeface="Calibri"/>
                         </a:rPr>
-                        <a:t>0.461</a:t>
+                        <a:t>0.1570</a:t>
                       </a:r>
                     </a:p>
                   </a:txBody>
@@ -13132,13 +13225,596 @@
                     <a:p>
                       <a:pPr algn="ctr"/>
                       <a:r>
-                        <a:rPr sz="1400" b="0" i="0">
+                        <a:rPr sz="1200" b="0" i="0">
                           <a:solidFill>
                             <a:srgbClr val="222222"/>
                           </a:solidFill>
                           <a:latin typeface="Calibri"/>
                         </a:rPr>
-                        <a:t>0.267</a:t>
+                        <a:t>0.1064</a:t>
+                      </a:r>
+                    </a:p>
+                  </a:txBody>
+                  <a:tcPr marL="54864" marR="54864" marT="18288" marB="18288" anchor="ctr">
+                    <a:solidFill>
+                      <a:srgbClr val="EEF2F7"/>
+                    </a:solidFill>
+                  </a:tcPr>
+                </a:tc>
+                <a:tc>
+                  <a:txBody>
+                    <a:bodyPr wrap="square"/>
+                    <a:lstStyle/>
+                    <a:p>
+                      <a:pPr algn="ctr"/>
+                      <a:r>
+                        <a:rPr sz="1200" b="0" i="0">
+                          <a:solidFill>
+                            <a:srgbClr val="222222"/>
+                          </a:solidFill>
+                          <a:latin typeface="Calibri"/>
+                        </a:rPr>
+                        <a:t>0.1770</a:t>
+                      </a:r>
+                    </a:p>
+                  </a:txBody>
+                  <a:tcPr marL="54864" marR="54864" marT="18288" marB="18288" anchor="ctr">
+                    <a:solidFill>
+                      <a:srgbClr val="EEF2F7"/>
+                    </a:solidFill>
+                  </a:tcPr>
+                </a:tc>
+              </a:tr>
+              <a:tr h="329184">
+                <a:tc>
+                  <a:txBody>
+                    <a:bodyPr wrap="square"/>
+                    <a:lstStyle/>
+                    <a:p>
+                      <a:pPr algn="l"/>
+                      <a:r>
+                        <a:rPr sz="1200" b="0" i="0">
+                          <a:solidFill>
+                            <a:srgbClr val="222222"/>
+                          </a:solidFill>
+                          <a:latin typeface="Calibri"/>
+                        </a:rPr>
+                        <a:t>SAS</a:t>
+                      </a:r>
+                    </a:p>
+                  </a:txBody>
+                  <a:tcPr marL="54864" marR="54864" marT="18288" marB="18288" anchor="ctr">
+                    <a:solidFill>
+                      <a:srgbClr val="FFFFFF"/>
+                    </a:solidFill>
+                  </a:tcPr>
+                </a:tc>
+                <a:tc>
+                  <a:txBody>
+                    <a:bodyPr wrap="square"/>
+                    <a:lstStyle/>
+                    <a:p>
+                      <a:pPr algn="ctr"/>
+                      <a:r>
+                        <a:rPr sz="1200" b="0" i="0">
+                          <a:solidFill>
+                            <a:srgbClr val="222222"/>
+                          </a:solidFill>
+                          <a:latin typeface="Calibri"/>
+                        </a:rPr>
+                        <a:t>3</a:t>
+                      </a:r>
+                    </a:p>
+                  </a:txBody>
+                  <a:tcPr marL="54864" marR="54864" marT="18288" marB="18288" anchor="ctr">
+                    <a:solidFill>
+                      <a:srgbClr val="FFFFFF"/>
+                    </a:solidFill>
+                  </a:tcPr>
+                </a:tc>
+                <a:tc>
+                  <a:txBody>
+                    <a:bodyPr wrap="square"/>
+                    <a:lstStyle/>
+                    <a:p>
+                      <a:pPr algn="ctr"/>
+                      <a:r>
+                        <a:rPr sz="1200" b="0" i="0">
+                          <a:solidFill>
+                            <a:srgbClr val="222222"/>
+                          </a:solidFill>
+                          <a:latin typeface="Calibri"/>
+                        </a:rPr>
+                        <a:t>0.5580</a:t>
+                      </a:r>
+                    </a:p>
+                  </a:txBody>
+                  <a:tcPr marL="54864" marR="54864" marT="18288" marB="18288" anchor="ctr">
+                    <a:solidFill>
+                      <a:srgbClr val="FFFFFF"/>
+                    </a:solidFill>
+                  </a:tcPr>
+                </a:tc>
+                <a:tc>
+                  <a:txBody>
+                    <a:bodyPr wrap="square"/>
+                    <a:lstStyle/>
+                    <a:p>
+                      <a:pPr algn="ctr"/>
+                      <a:r>
+                        <a:rPr sz="1200" b="0" i="0">
+                          <a:solidFill>
+                            <a:srgbClr val="222222"/>
+                          </a:solidFill>
+                          <a:latin typeface="Calibri"/>
+                        </a:rPr>
+                        <a:t>0.4183</a:t>
+                      </a:r>
+                    </a:p>
+                  </a:txBody>
+                  <a:tcPr marL="54864" marR="54864" marT="18288" marB="18288" anchor="ctr">
+                    <a:solidFill>
+                      <a:srgbClr val="FFFFFF"/>
+                    </a:solidFill>
+                  </a:tcPr>
+                </a:tc>
+                <a:tc>
+                  <a:txBody>
+                    <a:bodyPr wrap="square"/>
+                    <a:lstStyle/>
+                    <a:p>
+                      <a:pPr algn="ctr"/>
+                      <a:r>
+                        <a:rPr sz="1200" b="0" i="0">
+                          <a:solidFill>
+                            <a:srgbClr val="222222"/>
+                          </a:solidFill>
+                          <a:latin typeface="Calibri"/>
+                        </a:rPr>
+                        <a:t>0.2268</a:t>
+                      </a:r>
+                    </a:p>
+                  </a:txBody>
+                  <a:tcPr marL="54864" marR="54864" marT="18288" marB="18288" anchor="ctr">
+                    <a:solidFill>
+                      <a:srgbClr val="FFFFFF"/>
+                    </a:solidFill>
+                  </a:tcPr>
+                </a:tc>
+                <a:tc>
+                  <a:txBody>
+                    <a:bodyPr wrap="square"/>
+                    <a:lstStyle/>
+                    <a:p>
+                      <a:pPr algn="ctr"/>
+                      <a:r>
+                        <a:rPr sz="1200" b="0" i="0">
+                          <a:solidFill>
+                            <a:srgbClr val="222222"/>
+                          </a:solidFill>
+                          <a:latin typeface="Calibri"/>
+                        </a:rPr>
+                        <a:t>0.2176</a:t>
+                      </a:r>
+                    </a:p>
+                  </a:txBody>
+                  <a:tcPr marL="54864" marR="54864" marT="18288" marB="18288" anchor="ctr">
+                    <a:solidFill>
+                      <a:srgbClr val="FFFFFF"/>
+                    </a:solidFill>
+                  </a:tcPr>
+                </a:tc>
+              </a:tr>
+              <a:tr h="329184">
+                <a:tc>
+                  <a:txBody>
+                    <a:bodyPr wrap="square"/>
+                    <a:lstStyle/>
+                    <a:p>
+                      <a:pPr algn="l"/>
+                      <a:r>
+                        <a:rPr sz="1200" b="1" i="0">
+                          <a:solidFill>
+                            <a:srgbClr val="222222"/>
+                          </a:solidFill>
+                          <a:latin typeface="Calibri"/>
+                        </a:rPr>
+                        <a:t>SAS-SQN</a:t>
+                      </a:r>
+                    </a:p>
+                  </a:txBody>
+                  <a:tcPr marL="54864" marR="54864" marT="18288" marB="18288" anchor="ctr">
+                    <a:solidFill>
+                      <a:srgbClr val="EEF2F7"/>
+                    </a:solidFill>
+                  </a:tcPr>
+                </a:tc>
+                <a:tc>
+                  <a:txBody>
+                    <a:bodyPr wrap="square"/>
+                    <a:lstStyle/>
+                    <a:p>
+                      <a:pPr algn="ctr"/>
+                      <a:r>
+                        <a:rPr sz="1200" b="1" i="0">
+                          <a:solidFill>
+                            <a:srgbClr val="222222"/>
+                          </a:solidFill>
+                          <a:latin typeface="Calibri"/>
+                        </a:rPr>
+                        <a:t>5</a:t>
+                      </a:r>
+                    </a:p>
+                  </a:txBody>
+                  <a:tcPr marL="54864" marR="54864" marT="18288" marB="18288" anchor="ctr">
+                    <a:solidFill>
+                      <a:srgbClr val="EEF2F7"/>
+                    </a:solidFill>
+                  </a:tcPr>
+                </a:tc>
+                <a:tc>
+                  <a:txBody>
+                    <a:bodyPr wrap="square"/>
+                    <a:lstStyle/>
+                    <a:p>
+                      <a:pPr algn="ctr"/>
+                      <a:r>
+                        <a:rPr sz="1200" b="1" i="0">
+                          <a:solidFill>
+                            <a:srgbClr val="222222"/>
+                          </a:solidFill>
+                          <a:latin typeface="Calibri"/>
+                        </a:rPr>
+                        <a:t>0.5635</a:t>
+                      </a:r>
+                    </a:p>
+                  </a:txBody>
+                  <a:tcPr marL="54864" marR="54864" marT="18288" marB="18288" anchor="ctr">
+                    <a:solidFill>
+                      <a:srgbClr val="EEF2F7"/>
+                    </a:solidFill>
+                  </a:tcPr>
+                </a:tc>
+                <a:tc>
+                  <a:txBody>
+                    <a:bodyPr wrap="square"/>
+                    <a:lstStyle/>
+                    <a:p>
+                      <a:pPr algn="ctr"/>
+                      <a:r>
+                        <a:rPr sz="1200" b="1" i="0">
+                          <a:solidFill>
+                            <a:srgbClr val="222222"/>
+                          </a:solidFill>
+                          <a:latin typeface="Calibri"/>
+                        </a:rPr>
+                        <a:t>0.4479</a:t>
+                      </a:r>
+                    </a:p>
+                  </a:txBody>
+                  <a:tcPr marL="54864" marR="54864" marT="18288" marB="18288" anchor="ctr">
+                    <a:solidFill>
+                      <a:srgbClr val="EEF2F7"/>
+                    </a:solidFill>
+                  </a:tcPr>
+                </a:tc>
+                <a:tc>
+                  <a:txBody>
+                    <a:bodyPr wrap="square"/>
+                    <a:lstStyle/>
+                    <a:p>
+                      <a:pPr algn="ctr"/>
+                      <a:r>
+                        <a:rPr sz="1200" b="1" i="0">
+                          <a:solidFill>
+                            <a:srgbClr val="222222"/>
+                          </a:solidFill>
+                          <a:latin typeface="Calibri"/>
+                        </a:rPr>
+                        <a:t>0.2336</a:t>
+                      </a:r>
+                    </a:p>
+                  </a:txBody>
+                  <a:tcPr marL="54864" marR="54864" marT="18288" marB="18288" anchor="ctr">
+                    <a:solidFill>
+                      <a:srgbClr val="EEF2F7"/>
+                    </a:solidFill>
+                  </a:tcPr>
+                </a:tc>
+                <a:tc>
+                  <a:txBody>
+                    <a:bodyPr wrap="square"/>
+                    <a:lstStyle/>
+                    <a:p>
+                      <a:pPr algn="ctr"/>
+                      <a:r>
+                        <a:rPr sz="1200" b="1" i="0">
+                          <a:solidFill>
+                            <a:srgbClr val="222222"/>
+                          </a:solidFill>
+                          <a:latin typeface="Calibri"/>
+                        </a:rPr>
+                        <a:t>0.2634</a:t>
+                      </a:r>
+                    </a:p>
+                  </a:txBody>
+                  <a:tcPr marL="54864" marR="54864" marT="18288" marB="18288" anchor="ctr">
+                    <a:solidFill>
+                      <a:srgbClr val="EEF2F7"/>
+                    </a:solidFill>
+                  </a:tcPr>
+                </a:tc>
+              </a:tr>
+              <a:tr h="329184">
+                <a:tc>
+                  <a:txBody>
+                    <a:bodyPr wrap="square"/>
+                    <a:lstStyle/>
+                    <a:p>
+                      <a:pPr algn="l"/>
+                      <a:r>
+                        <a:rPr sz="1200" b="1" i="0">
+                          <a:solidFill>
+                            <a:srgbClr val="222222"/>
+                          </a:solidFill>
+                          <a:latin typeface="Calibri"/>
+                        </a:rPr>
+                        <a:t>SAS-EVAL</a:t>
+                      </a:r>
+                    </a:p>
+                  </a:txBody>
+                  <a:tcPr marL="54864" marR="54864" marT="18288" marB="18288" anchor="ctr">
+                    <a:solidFill>
+                      <a:srgbClr val="FFFFFF"/>
+                    </a:solidFill>
+                  </a:tcPr>
+                </a:tc>
+                <a:tc>
+                  <a:txBody>
+                    <a:bodyPr wrap="square"/>
+                    <a:lstStyle/>
+                    <a:p>
+                      <a:pPr algn="ctr"/>
+                      <a:r>
+                        <a:rPr sz="1200" b="1" i="0">
+                          <a:solidFill>
+                            <a:srgbClr val="222222"/>
+                          </a:solidFill>
+                          <a:latin typeface="Calibri"/>
+                        </a:rPr>
+                        <a:t>5</a:t>
+                      </a:r>
+                    </a:p>
+                  </a:txBody>
+                  <a:tcPr marL="54864" marR="54864" marT="18288" marB="18288" anchor="ctr">
+                    <a:solidFill>
+                      <a:srgbClr val="FFFFFF"/>
+                    </a:solidFill>
+                  </a:tcPr>
+                </a:tc>
+                <a:tc>
+                  <a:txBody>
+                    <a:bodyPr wrap="square"/>
+                    <a:lstStyle/>
+                    <a:p>
+                      <a:pPr algn="ctr"/>
+                      <a:r>
+                        <a:rPr sz="1200" b="1" i="0">
+                          <a:solidFill>
+                            <a:srgbClr val="222222"/>
+                          </a:solidFill>
+                          <a:latin typeface="Calibri"/>
+                        </a:rPr>
+                        <a:t>0.5810</a:t>
+                      </a:r>
+                    </a:p>
+                  </a:txBody>
+                  <a:tcPr marL="54864" marR="54864" marT="18288" marB="18288" anchor="ctr">
+                    <a:solidFill>
+                      <a:srgbClr val="FFFFFF"/>
+                    </a:solidFill>
+                  </a:tcPr>
+                </a:tc>
+                <a:tc>
+                  <a:txBody>
+                    <a:bodyPr wrap="square"/>
+                    <a:lstStyle/>
+                    <a:p>
+                      <a:pPr algn="ctr"/>
+                      <a:r>
+                        <a:rPr sz="1200" b="1" i="0">
+                          <a:solidFill>
+                            <a:srgbClr val="222222"/>
+                          </a:solidFill>
+                          <a:latin typeface="Calibri"/>
+                        </a:rPr>
+                        <a:t>0.4504</a:t>
+                      </a:r>
+                    </a:p>
+                  </a:txBody>
+                  <a:tcPr marL="54864" marR="54864" marT="18288" marB="18288" anchor="ctr">
+                    <a:solidFill>
+                      <a:srgbClr val="FFFFFF"/>
+                    </a:solidFill>
+                  </a:tcPr>
+                </a:tc>
+                <a:tc>
+                  <a:txBody>
+                    <a:bodyPr wrap="square"/>
+                    <a:lstStyle/>
+                    <a:p>
+                      <a:pPr algn="ctr"/>
+                      <a:r>
+                        <a:rPr sz="1200" b="1" i="0">
+                          <a:solidFill>
+                            <a:srgbClr val="222222"/>
+                          </a:solidFill>
+                          <a:latin typeface="Calibri"/>
+                        </a:rPr>
+                        <a:t>0.2402</a:t>
+                      </a:r>
+                    </a:p>
+                  </a:txBody>
+                  <a:tcPr marL="54864" marR="54864" marT="18288" marB="18288" anchor="ctr">
+                    <a:solidFill>
+                      <a:srgbClr val="FFFFFF"/>
+                    </a:solidFill>
+                  </a:tcPr>
+                </a:tc>
+                <a:tc>
+                  <a:txBody>
+                    <a:bodyPr wrap="square"/>
+                    <a:lstStyle/>
+                    <a:p>
+                      <a:pPr algn="ctr"/>
+                      <a:r>
+                        <a:rPr sz="1200" b="1" i="0">
+                          <a:solidFill>
+                            <a:srgbClr val="222222"/>
+                          </a:solidFill>
+                          <a:latin typeface="Calibri"/>
+                        </a:rPr>
+                        <a:t>0.2600</a:t>
+                      </a:r>
+                    </a:p>
+                  </a:txBody>
+                  <a:tcPr marL="54864" marR="54864" marT="18288" marB="18288" anchor="ctr">
+                    <a:solidFill>
+                      <a:srgbClr val="FFFFFF"/>
+                    </a:solidFill>
+                  </a:tcPr>
+                </a:tc>
+              </a:tr>
+              <a:tr h="329184">
+                <a:tc>
+                  <a:txBody>
+                    <a:bodyPr wrap="square"/>
+                    <a:lstStyle/>
+                    <a:p>
+                      <a:pPr algn="l"/>
+                      <a:r>
+                        <a:rPr sz="1200" b="0" i="0">
+                          <a:solidFill>
+                            <a:srgbClr val="222222"/>
+                          </a:solidFill>
+                          <a:latin typeface="Calibri"/>
+                        </a:rPr>
+                        <a:t>SAS-HIST</a:t>
+                      </a:r>
+                    </a:p>
+                  </a:txBody>
+                  <a:tcPr marL="54864" marR="54864" marT="18288" marB="18288" anchor="ctr">
+                    <a:solidFill>
+                      <a:srgbClr val="EEF2F7"/>
+                    </a:solidFill>
+                  </a:tcPr>
+                </a:tc>
+                <a:tc>
+                  <a:txBody>
+                    <a:bodyPr wrap="square"/>
+                    <a:lstStyle/>
+                    <a:p>
+                      <a:pPr algn="ctr"/>
+                      <a:r>
+                        <a:rPr sz="1200" b="0" i="0">
+                          <a:solidFill>
+                            <a:srgbClr val="222222"/>
+                          </a:solidFill>
+                          <a:latin typeface="Calibri"/>
+                        </a:rPr>
+                        <a:t>3</a:t>
+                      </a:r>
+                    </a:p>
+                  </a:txBody>
+                  <a:tcPr marL="54864" marR="54864" marT="18288" marB="18288" anchor="ctr">
+                    <a:solidFill>
+                      <a:srgbClr val="EEF2F7"/>
+                    </a:solidFill>
+                  </a:tcPr>
+                </a:tc>
+                <a:tc>
+                  <a:txBody>
+                    <a:bodyPr wrap="square"/>
+                    <a:lstStyle/>
+                    <a:p>
+                      <a:pPr algn="ctr"/>
+                      <a:r>
+                        <a:rPr sz="1200" b="0" i="0">
+                          <a:solidFill>
+                            <a:srgbClr val="222222"/>
+                          </a:solidFill>
+                          <a:latin typeface="Calibri"/>
+                        </a:rPr>
+                        <a:t>0.2128</a:t>
+                      </a:r>
+                    </a:p>
+                  </a:txBody>
+                  <a:tcPr marL="54864" marR="54864" marT="18288" marB="18288" anchor="ctr">
+                    <a:solidFill>
+                      <a:srgbClr val="EEF2F7"/>
+                    </a:solidFill>
+                  </a:tcPr>
+                </a:tc>
+                <a:tc>
+                  <a:txBody>
+                    <a:bodyPr wrap="square"/>
+                    <a:lstStyle/>
+                    <a:p>
+                      <a:pPr algn="ctr"/>
+                      <a:r>
+                        <a:rPr sz="1200" b="0" i="0">
+                          <a:solidFill>
+                            <a:srgbClr val="222222"/>
+                          </a:solidFill>
+                          <a:latin typeface="Calibri"/>
+                        </a:rPr>
+                        <a:t>0.1518</a:t>
+                      </a:r>
+                    </a:p>
+                  </a:txBody>
+                  <a:tcPr marL="54864" marR="54864" marT="18288" marB="18288" anchor="ctr">
+                    <a:solidFill>
+                      <a:srgbClr val="EEF2F7"/>
+                    </a:solidFill>
+                  </a:tcPr>
+                </a:tc>
+                <a:tc>
+                  <a:txBody>
+                    <a:bodyPr wrap="square"/>
+                    <a:lstStyle/>
+                    <a:p>
+                      <a:pPr algn="ctr"/>
+                      <a:r>
+                        <a:rPr sz="1200" b="0" i="0">
+                          <a:solidFill>
+                            <a:srgbClr val="222222"/>
+                          </a:solidFill>
+                          <a:latin typeface="Calibri"/>
+                        </a:rPr>
+                        <a:t>0.0663</a:t>
+                      </a:r>
+                    </a:p>
+                  </a:txBody>
+                  <a:tcPr marL="54864" marR="54864" marT="18288" marB="18288" anchor="ctr">
+                    <a:solidFill>
+                      <a:srgbClr val="EEF2F7"/>
+                    </a:solidFill>
+                  </a:tcPr>
+                </a:tc>
+                <a:tc>
+                  <a:txBody>
+                    <a:bodyPr wrap="square"/>
+                    <a:lstStyle/>
+                    <a:p>
+                      <a:pPr algn="ctr"/>
+                      <a:r>
+                        <a:rPr sz="1200" b="0" i="0">
+                          <a:solidFill>
+                            <a:srgbClr val="222222"/>
+                          </a:solidFill>
+                          <a:latin typeface="Calibri"/>
+                        </a:rPr>
+                        <a:t>0.2573</a:t>
                       </a:r>
                     </a:p>
                   </a:txBody>
@@ -13161,8 +13837,8 @@
         </p:nvSpPr>
         <p:spPr>
           <a:xfrm>
-            <a:off x="548640" y="4206240"/>
-            <a:ext cx="6766560" cy="365760"/>
+            <a:off x="548640" y="4983479"/>
+            <a:ext cx="6858000" cy="320040"/>
           </a:xfrm>
           <a:prstGeom prst="rect">
             <a:avLst/>
@@ -13183,34 +13859,155 @@
                 </a:solidFill>
                 <a:latin typeface="Calibri"/>
               </a:rPr>
-              <a:t>Partial CPU run: 1 seed, 2-3 epochs (full table in report)</a:t>
-            </a:r>
-          </a:p>
-        </p:txBody>
-      </p:sp>
-      <p:sp>
-        <p:nvSpPr>
-          <p:cNvPr id="8" name="Rounded Rectangle 7"/>
+              <a:t>Colab T4 GPU, full grid, 1 seed (paper: 5); test metrics at best validation purchase NDCG@20</a:t>
+            </a:r>
+          </a:p>
+        </p:txBody>
+      </p:sp>
+      <p:sp>
+        <p:nvSpPr>
+          <p:cNvPr id="8" name="TextBox 7"/>
+          <p:cNvSpPr txBox="1"/>
+          <p:nvPr/>
+        </p:nvSpPr>
+        <p:spPr>
+          <a:xfrm>
+            <a:off x="7680960" y="1965960"/>
+            <a:ext cx="3977639" cy="3383280"/>
+          </a:xfrm>
+          <a:prstGeom prst="rect">
+            <a:avLst/>
+          </a:prstGeom>
+          <a:noFill/>
+        </p:spPr>
+        <p:txBody>
+          <a:bodyPr wrap="square">
+            <a:spAutoFit/>
+          </a:bodyPr>
+          <a:lstStyle/>
+          <a:p>
+            <a:pPr>
+              <a:spcAft>
+                <a:spcPts val="800"/>
+              </a:spcAft>
+            </a:pPr>
+            <a:r>
+              <a:rPr sz="900" b="0" i="0">
+                <a:solidFill>
+                  <a:srgbClr val="1F3A5F"/>
+                </a:solidFill>
+                <a:latin typeface="Calibri"/>
+              </a:rPr>
+              <a:t>■  </a:t>
+            </a:r>
+            <a:r>
+              <a:rPr sz="1500" b="1" i="0">
+                <a:solidFill>
+                  <a:srgbClr val="1F3A5F"/>
+                </a:solidFill>
+                <a:latin typeface="Calibri"/>
+              </a:rPr>
+              <a:t>SASRec reproduces:</a:t>
+            </a:r>
+            <a:r>
+              <a:rPr sz="1500" b="0" i="0">
+                <a:solidFill>
+                  <a:srgbClr val="222222"/>
+                </a:solidFill>
+                <a:latin typeface="Calibri"/>
+              </a:rPr>
+              <a:t> SQN +7%, EVAL +8% purchase NDCG@20 (0.448 / 0.450 vs 0.418); EVAL has no RL</a:t>
+            </a:r>
+          </a:p>
+          <a:p>
+            <a:pPr>
+              <a:spcAft>
+                <a:spcPts val="800"/>
+              </a:spcAft>
+            </a:pPr>
+            <a:r>
+              <a:rPr sz="900" b="0" i="0">
+                <a:solidFill>
+                  <a:srgbClr val="1F3A5F"/>
+                </a:solidFill>
+                <a:latin typeface="Calibri"/>
+              </a:rPr>
+              <a:t>■  </a:t>
+            </a:r>
+            <a:r>
+              <a:rPr sz="1500" b="1" i="0">
+                <a:solidFill>
+                  <a:srgbClr val="1F3A5F"/>
+                </a:solidFill>
+                <a:latin typeface="Calibri"/>
+              </a:rPr>
+              <a:t>GRU4Rec: no gain</a:t>
+            </a:r>
+            <a:r>
+              <a:rPr sz="1500" b="0" i="0">
+                <a:solidFill>
+                  <a:srgbClr val="222222"/>
+                </a:solidFill>
+                <a:latin typeface="Calibri"/>
+              </a:rPr>
+              <a:t> (CE 0.342 vs SQN 0.323, EVAL 0.339); one seed, may be noise</a:t>
+            </a:r>
+          </a:p>
+          <a:p>
+            <a:pPr>
+              <a:spcAft>
+                <a:spcPts val="800"/>
+              </a:spcAft>
+            </a:pPr>
+            <a:r>
+              <a:rPr sz="900" b="0" i="0">
+                <a:solidFill>
+                  <a:srgbClr val="1F3A5F"/>
+                </a:solidFill>
+                <a:latin typeface="Calibri"/>
+              </a:rPr>
+              <a:t>■  </a:t>
+            </a:r>
+            <a:r>
+              <a:rPr sz="1500" b="1" i="0">
+                <a:solidFill>
+                  <a:srgbClr val="1F3A5F"/>
+                </a:solidFill>
+                <a:latin typeface="Calibri"/>
+              </a:rPr>
+              <a:t>HIST fails (≈0.15):</a:t>
+            </a:r>
+            <a:r>
+              <a:rPr sz="1500" b="0" i="0">
+                <a:solidFill>
+                  <a:srgbClr val="222222"/>
+                </a:solidFill>
+                <a:latin typeface="Calibri"/>
+              </a:rPr>
+              <a:t> unnormalised MSE on raw counts swamps CE; our bug, fix with log(1+n)</a:t>
+            </a:r>
+          </a:p>
+        </p:txBody>
+      </p:sp>
+      <p:sp>
+        <p:nvSpPr>
+          <p:cNvPr id="9" name="Rectangle 8"/>
           <p:cNvSpPr/>
           <p:nvPr/>
         </p:nvSpPr>
         <p:spPr>
           <a:xfrm>
-            <a:off x="7680960" y="2148840"/>
-            <a:ext cx="3931920" cy="2377440"/>
+            <a:off x="548640" y="5394960"/>
+            <a:ext cx="11094415" cy="640080"/>
           </a:xfrm>
-          <a:prstGeom prst="roundRect">
-            <a:avLst>
-              <a:gd name="adj" fmla="val 8000"/>
-            </a:avLst>
+          <a:prstGeom prst="rect">
+            <a:avLst/>
           </a:prstGeom>
           <a:solidFill>
-            <a:srgbClr val="EEF2F7"/>
+            <a:srgbClr val="1F3A5F"/>
           </a:solidFill>
-          <a:ln w="15875">
-            <a:solidFill>
-              <a:srgbClr val="1F3A5F"/>
-            </a:solidFill>
+          <a:ln>
+            <a:noFill/>
           </a:ln>
         </p:spPr>
         <p:style>
@@ -13228,184 +14025,18 @@
           </a:fontRef>
         </p:style>
         <p:txBody>
-          <a:bodyPr rtlCol="0" anchor="t" wrap="square" lIns="137160" rIns="137160" tIns="91440"/>
+          <a:bodyPr rtlCol="0" anchor="ctr" wrap="square" lIns="182880"/>
           <a:lstStyle/>
           <a:p>
             <a:pPr algn="ctr"/>
             <a:r>
               <a:rPr sz="1600" b="1" i="0">
                 <a:solidFill>
-                  <a:srgbClr val="1F3A5F"/>
-                </a:solidFill>
-                <a:latin typeface="Calibri"/>
-              </a:rPr>
-              <a:t>Repeat-item finding</a:t>
-            </a:r>
-          </a:p>
-          <a:p>
-            <a:pPr>
-              <a:spcBef>
-                <a:spcPts val="500"/>
-              </a:spcBef>
-            </a:pPr>
-            <a:r>
-              <a:rPr sz="1500" b="1" i="0">
-                <a:solidFill>
-                  <a:srgbClr val="1F3A5F"/>
-                </a:solidFill>
-                <a:latin typeface="Calibri"/>
-              </a:rPr>
-              <a:t>67%</a:t>
-            </a:r>
-            <a:r>
-              <a:rPr sz="1500" b="0" i="0">
-                <a:solidFill>
-                  <a:srgbClr val="222222"/>
-                </a:solidFill>
-                <a:latin typeface="Calibri"/>
-              </a:rPr>
-              <a:t> of purchase targets = the item viewed just before (73% in 10-item history)</a:t>
-            </a:r>
-          </a:p>
-          <a:p>
-            <a:pPr>
-              <a:spcBef>
-                <a:spcPts val="500"/>
-              </a:spcBef>
-            </a:pPr>
-            <a:r>
-              <a:rPr sz="1500" b="0" i="0">
-                <a:solidFill>
-                  <a:srgbClr val="222222"/>
-                </a:solidFill>
-                <a:latin typeface="Calibri"/>
-              </a:rPr>
-              <a:t>Explains purchase HR@20 ≈ 2× the paper's (0.46 vs 0.23)</a:t>
-            </a:r>
-          </a:p>
-        </p:txBody>
-      </p:sp>
-      <p:sp>
-        <p:nvSpPr>
-          <p:cNvPr id="9" name="TextBox 8"/>
-          <p:cNvSpPr txBox="1"/>
-          <p:nvPr/>
-        </p:nvSpPr>
-        <p:spPr>
-          <a:xfrm>
-            <a:off x="548640" y="4663440"/>
-            <a:ext cx="11094415" cy="1371600"/>
-          </a:xfrm>
-          <a:prstGeom prst="rect">
-            <a:avLst/>
-          </a:prstGeom>
-          <a:noFill/>
-        </p:spPr>
-        <p:txBody>
-          <a:bodyPr wrap="square">
-            <a:spAutoFit/>
-          </a:bodyPr>
-          <a:lstStyle/>
-          <a:p>
-            <a:pPr>
-              <a:spcAft>
-                <a:spcPts val="600"/>
-              </a:spcAft>
-            </a:pPr>
-            <a:r>
-              <a:rPr sz="1000" b="0" i="0">
-                <a:solidFill>
-                  <a:srgbClr val="1F3A5F"/>
-                </a:solidFill>
-                <a:latin typeface="Calibri"/>
-              </a:rPr>
-              <a:t>■  </a:t>
-            </a:r>
-            <a:r>
-              <a:rPr sz="1600" b="0" i="0">
-                <a:solidFill>
-                  <a:srgbClr val="222222"/>
-                </a:solidFill>
-                <a:latin typeface="Calibri"/>
-              </a:rPr>
-              <a:t>Setup as SQN: views = clicks, add-to-cart = purchases; data matches paper (195,524 sessions, 70,852 items)</a:t>
-            </a:r>
-          </a:p>
-          <a:p>
-            <a:pPr>
-              <a:spcAft>
-                <a:spcPts val="600"/>
-              </a:spcAft>
-            </a:pPr>
-            <a:r>
-              <a:rPr sz="1000" b="0" i="0">
-                <a:solidFill>
-                  <a:srgbClr val="1F3A5F"/>
-                </a:solidFill>
-                <a:latin typeface="Calibri"/>
-              </a:rPr>
-              <a:t>■  </a:t>
-            </a:r>
-            <a:r>
-              <a:rPr sz="1600" b="0" i="0">
-                <a:solidFill>
-                  <a:srgbClr val="222222"/>
-                </a:solidFill>
-                <a:latin typeface="Calibri"/>
-              </a:rPr>
-              <a:t>Compare </a:t>
-            </a:r>
-            <a:r>
-              <a:rPr sz="1600" b="1" i="0">
-                <a:solidFill>
-                  <a:srgbClr val="1F3A5F"/>
-                </a:solidFill>
-                <a:latin typeface="Calibri"/>
-              </a:rPr>
-              <a:t>relative</a:t>
-            </a:r>
-            <a:r>
-              <a:rPr sz="1600" b="0" i="0">
-                <a:solidFill>
-                  <a:srgbClr val="222222"/>
-                </a:solidFill>
-                <a:latin typeface="Calibri"/>
-              </a:rPr>
-              <a:t> gains between heads; SQN &lt; CE after 2-3 epochs is too early to judge</a:t>
-            </a:r>
-          </a:p>
-          <a:p>
-            <a:pPr>
-              <a:spcAft>
-                <a:spcPts val="600"/>
-              </a:spcAft>
-            </a:pPr>
-            <a:r>
-              <a:rPr sz="1000" b="0" i="0">
-                <a:solidFill>
-                  <a:srgbClr val="1F3A5F"/>
-                </a:solidFill>
-                <a:latin typeface="Calibri"/>
-              </a:rPr>
-              <a:t>■  </a:t>
-            </a:r>
-            <a:r>
-              <a:rPr sz="1600" b="1" i="0">
-                <a:solidFill>
-                  <a:srgbClr val="1F3A5F"/>
-                </a:solidFill>
-                <a:latin typeface="Calibri"/>
-              </a:rPr>
-              <a:t>Status:</a:t>
-            </a:r>
-            <a:r>
-              <a:rPr sz="1600" b="0" i="0">
-                <a:solidFill>
-                  <a:srgbClr val="222222"/>
-                </a:solidFill>
-                <a:latin typeface="Calibri"/>
-              </a:rPr>
-              <a:t> full grid (8 models × 5 seeds) running on Colab GPU</a:t>
+                  <a:srgbClr val="FFFFFF"/>
+                </a:solidFill>
+                <a:latin typeface="Calibri"/>
+              </a:rPr>
+              <a:t>Repeat items: 67% of purchase targets = the item just viewed, so absolute metrics ≈ 2× the paper's; compare relative gains</a:t>
             </a:r>
           </a:p>
         </p:txBody>

</xml_diff>